<commit_message>
Parts GP tracking lever: monitor and actively manage
Co-Authored-By: Claude Opus 5.5 <noreply@anthropic.com>
Claude-Session: https://claude.ai/code/session_01Xa4nFVxuQGXmHARGph9WhS
</commit_message>
<xml_diff>
--- a/day2-deck/decks/Changes - Oct 26 (round 4).pptx
+++ b/day2-deck/decks/Changes - Oct 26 (round 4).pptx
@@ -891,6 +891,10 @@
           </a:solidFill>
           <a:ln/>
         </p:spPr>
+        <p:txBody>
+          <a:bodyPr/>
+          <a:p/>
+        </p:txBody>
       </p:sp>
       <p:sp>
         <p:nvSpPr>
@@ -989,6 +993,10 @@
           </a:solidFill>
           <a:ln/>
         </p:spPr>
+        <p:txBody>
+          <a:bodyPr/>
+          <a:p/>
+        </p:txBody>
       </p:sp>
       <p:sp>
         <p:nvSpPr>
@@ -1173,6 +1181,10 @@
           </a:solidFill>
           <a:ln/>
         </p:spPr>
+        <p:txBody>
+          <a:bodyPr/>
+          <a:p/>
+        </p:txBody>
       </p:sp>
       <p:sp>
         <p:nvSpPr>
@@ -1193,6 +1205,10 @@
           </a:solidFill>
           <a:ln/>
         </p:spPr>
+        <p:txBody>
+          <a:bodyPr/>
+          <a:p/>
+        </p:txBody>
       </p:sp>
       <p:sp>
         <p:nvSpPr>
@@ -1397,6 +1413,10 @@
           </a:solidFill>
           <a:ln/>
         </p:spPr>
+        <p:txBody>
+          <a:bodyPr/>
+          <a:p/>
+        </p:txBody>
       </p:sp>
       <p:sp>
         <p:nvSpPr>
@@ -1473,6 +1493,10 @@
           </a:solidFill>
           <a:ln/>
         </p:spPr>
+        <p:txBody>
+          <a:bodyPr/>
+          <a:p/>
+        </p:txBody>
       </p:sp>
       <p:sp>
         <p:nvSpPr>
@@ -1549,6 +1573,10 @@
           </a:solidFill>
           <a:ln/>
         </p:spPr>
+        <p:txBody>
+          <a:bodyPr/>
+          <a:p/>
+        </p:txBody>
       </p:sp>
       <p:sp>
         <p:nvSpPr>
@@ -1625,6 +1653,10 @@
           </a:solidFill>
           <a:ln/>
         </p:spPr>
+        <p:txBody>
+          <a:bodyPr/>
+          <a:p/>
+        </p:txBody>
       </p:sp>
       <p:sp>
         <p:nvSpPr>
@@ -1701,6 +1733,10 @@
           </a:solidFill>
           <a:ln/>
         </p:spPr>
+        <p:txBody>
+          <a:bodyPr/>
+          <a:p/>
+        </p:txBody>
       </p:sp>
       <p:sp>
         <p:nvSpPr>
@@ -1777,6 +1813,10 @@
           </a:solidFill>
           <a:ln/>
         </p:spPr>
+        <p:txBody>
+          <a:bodyPr/>
+          <a:p/>
+        </p:txBody>
       </p:sp>
       <p:sp>
         <p:nvSpPr>
@@ -1828,7 +1868,7 @@
                 <a:ea typeface="Inter" pitchFamily="34" charset="-122"/>
                 <a:cs typeface="Inter" pitchFamily="34" charset="-120"/>
               </a:rPr>
-              <a:t>Know your parts GP % every day, know where you stand, and adjust as needed</a:t>
+              <a:t>Monitor and actively manage your parts GP %: know where you stand and adjust as needed</a:t>
             </a:r>
             <a:endParaRPr lang="en-US" sz="1400" dirty="0"/>
           </a:p>
@@ -1853,6 +1893,10 @@
           </a:solidFill>
           <a:ln/>
         </p:spPr>
+        <p:txBody>
+          <a:bodyPr/>
+          <a:p/>
+        </p:txBody>
       </p:sp>
       <p:sp>
         <p:nvSpPr>

</xml_diff>